<commit_message>
Scoring v1.4.0: evaluate off-hours relative to each sender
The fixed 22:00-06:00 window was unusable (28% of email, shifted header
times), so T-OFF-HOURS was "not evaluated". It is now evaluated against
the sender's own hourly pattern: +5 when 5% or less of that sender's
emails fall within +/-1 h of this email's header hour (needs 50+ dated
emails, else "not evaluated"). A constant corpus-wide shift moves all of
a sender's emails equally, so it cancels out (unit-tested).

- Fires on 6 of 114 flagged emails; not evaluated on 34 (low volume)
- Timing cap 10; app, deck, docs and annotation sheet updated
- 58 tests pass
</commit_message>
<xml_diff>
--- a/docs/Enron_Insight_2_slides.pptx
+++ b/docs/Enron_Insight_2_slides.pptx
@@ -973,7 +973,7 @@
           <a:lstStyle/>
           <a:p>
             <a:r>
-              <a:t>Task 3: an email is only flagged if the sender's own words ask to destroy records, keep something off the books, keep it secret or avoid a written record. Phrases are weighted strong, medium or weak; outside, rare or few recipients and weekend sending only add points. Off-hours is not evaluated because header times are shifted. Task 4: 1008 emails contain any phrase at all; filters for disclaimers, IT notices, negations leave 304, and setting aside press and bulk senders leaves 114 flagged. Each flag shows its sentence, score breakdown and source files. Precision is measured on top 20 plus 20 random flags by two independent reviewers.</a:t>
+              <a:t>Task 3: an email is only flagged if the sender's own words ask to destroy records, keep something off the books, keep it secret or avoid a written record. Phrases are weighted strong, medium or weak; outside, rare or few recipients, weekend sending, and sending at an hour the sender rarely uses only add points. Off-hours is measured against each sender's own hourly pattern, so the corpus-wide header-time shift does not matter. Task 4: 1008 emails contain any phrase at all; filters for disclaimers, IT notices, negations leave 304, and setting aside press and bulk senders leaves 114 flagged. Each flag shows its sentence, score breakdown and source files. Precision is measured on top 20 plus 20 random flags by two independent reviewers.</a:t>
             </a:r>
           </a:p>
         </p:txBody>
@@ -5898,7 +5898,7 @@
                 </a:solidFill>
                 <a:latin typeface="Calibri"/>
               </a:rPr>
-              <a:t>+5</a:t>
+              <a:t>+5 each</a:t>
             </a:r>
           </a:p>
         </p:txBody>
@@ -5937,7 +5937,7 @@
                 </a:solidFill>
                 <a:latin typeface="Calibri"/>
               </a:rPr>
-              <a:t>weekend  (header hours unreliable → off-hours not evaluated)</a:t>
+              <a:t>weekend · an hour this sender rarely uses (vs. own baseline)</a:t>
             </a:r>
           </a:p>
         </p:txBody>
@@ -6488,7 +6488,7 @@
                 </a:solidFill>
                 <a:latin typeface="Calibri"/>
               </a:rPr>
-              <a:t>“I would like to take this risk off the books.”</a:t>
+              <a:t>“Is there any way these trades can change be cleared off the books so that Risk Management can stop running the …”</a:t>
             </a:r>
           </a:p>
         </p:txBody>
@@ -6536,7 +6536,7 @@
                 </a:solidFill>
                 <a:latin typeface="Calibri"/>
               </a:rPr>
-              <a:t>54 automated tests · end-to-end pipeline test</a:t>
+              <a:t>58 automated tests · end-to-end pipeline test</a:t>
             </a:r>
           </a:p>
           <a:p>

</xml_diff>